<commit_message>
Fix #1203 add missing thumbnail for TermSet tutorial
</commit_message>
<xml_diff>
--- a/docs/source/figures/gallery_thumbnails.pptx
+++ b/docs/source/figures/gallery_thumbnails.pptx
@@ -5,7 +5,7 @@
     <p:sldMasterId id="2147483660" r:id="rId1"/>
   </p:sldMasterIdLst>
   <p:notesMasterIdLst>
-    <p:notesMasterId r:id="rId7"/>
+    <p:notesMasterId r:id="rId8"/>
   </p:notesMasterIdLst>
   <p:sldIdLst>
     <p:sldId id="342" r:id="rId2"/>
@@ -13,6 +13,7 @@
     <p:sldId id="344" r:id="rId4"/>
     <p:sldId id="345" r:id="rId5"/>
     <p:sldId id="346" r:id="rId6"/>
+    <p:sldId id="367" r:id="rId7"/>
   </p:sldIdLst>
   <p:sldSz cx="12192000" cy="6858000"/>
   <p:notesSz cx="6858000" cy="9144000"/>
@@ -212,7 +213,7 @@
           <a:p>
             <a:fld id="{4D6A40B9-902A-4E0E-AF39-1C357549AEE0}" type="datetimeFigureOut">
               <a:rPr lang="en-US" smtClean="0"/>
-              <a:t>4/21/22</a:t>
+              <a:t>11/7/24</a:t>
             </a:fld>
             <a:endParaRPr lang="en-US"/>
           </a:p>
@@ -14036,6 +14037,214 @@
 </p:sld>
 </file>
 
+<file path=ppt/slides/slide6.xml><?xml version="1.0" encoding="utf-8"?>
+<p:sld xmlns:a="http://schemas.openxmlformats.org/drawingml/2006/main" xmlns:r="http://schemas.openxmlformats.org/officeDocument/2006/relationships" xmlns:p="http://schemas.openxmlformats.org/presentationml/2006/main">
+  <p:cSld>
+    <p:spTree>
+      <p:nvGrpSpPr>
+        <p:cNvPr id="1" name="">
+          <a:extLst>
+            <a:ext uri="{FF2B5EF4-FFF2-40B4-BE49-F238E27FC236}">
+              <a16:creationId xmlns:a16="http://schemas.microsoft.com/office/drawing/2014/main" id="{71E4B4A6-73B7-86C7-8670-46D8D41DD2E0}"/>
+            </a:ext>
+          </a:extLst>
+        </p:cNvPr>
+        <p:cNvGrpSpPr/>
+        <p:nvPr/>
+      </p:nvGrpSpPr>
+      <p:grpSpPr>
+        <a:xfrm>
+          <a:off x="0" y="0"/>
+          <a:ext cx="0" cy="0"/>
+          <a:chOff x="0" y="0"/>
+          <a:chExt cx="0" cy="0"/>
+        </a:xfrm>
+      </p:grpSpPr>
+      <p:sp>
+        <p:nvSpPr>
+          <p:cNvPr id="27" name="Rounded Rectangle 26">
+            <a:extLst>
+              <a:ext uri="{FF2B5EF4-FFF2-40B4-BE49-F238E27FC236}">
+                <a16:creationId xmlns:a16="http://schemas.microsoft.com/office/drawing/2014/main" id="{5BC30344-1E85-01AE-B374-65D2A28A5CE4}"/>
+              </a:ext>
+            </a:extLst>
+          </p:cNvPr>
+          <p:cNvSpPr/>
+          <p:nvPr/>
+        </p:nvSpPr>
+        <p:spPr>
+          <a:xfrm>
+            <a:off x="853570" y="853671"/>
+            <a:ext cx="7234527" cy="4851352"/>
+          </a:xfrm>
+          <a:prstGeom prst="roundRect">
+            <a:avLst>
+              <a:gd name="adj" fmla="val 4437"/>
+            </a:avLst>
+          </a:prstGeom>
+          <a:solidFill>
+            <a:srgbClr val="EDEDED"/>
+          </a:solidFill>
+          <a:ln>
+            <a:solidFill>
+              <a:srgbClr val="000000"/>
+            </a:solidFill>
+          </a:ln>
+          <a:effectLst/>
+        </p:spPr>
+        <p:style>
+          <a:lnRef idx="1">
+            <a:schemeClr val="accent1"/>
+          </a:lnRef>
+          <a:fillRef idx="3">
+            <a:schemeClr val="accent1"/>
+          </a:fillRef>
+          <a:effectRef idx="2">
+            <a:schemeClr val="accent1"/>
+          </a:effectRef>
+          <a:fontRef idx="minor">
+            <a:schemeClr val="lt1"/>
+          </a:fontRef>
+        </p:style>
+        <p:txBody>
+          <a:bodyPr rtlCol="0" anchor="ctr"/>
+          <a:lstStyle/>
+          <a:p>
+            <a:pPr algn="ctr"/>
+            <a:endParaRPr lang="en-US"/>
+          </a:p>
+        </p:txBody>
+      </p:sp>
+      <p:sp>
+        <p:nvSpPr>
+          <p:cNvPr id="26" name="Rectangle 25">
+            <a:extLst>
+              <a:ext uri="{FF2B5EF4-FFF2-40B4-BE49-F238E27FC236}">
+                <a16:creationId xmlns:a16="http://schemas.microsoft.com/office/drawing/2014/main" id="{217F646C-9719-14B7-7C33-4C1EDEE3A37C}"/>
+              </a:ext>
+            </a:extLst>
+          </p:cNvPr>
+          <p:cNvSpPr/>
+          <p:nvPr/>
+        </p:nvSpPr>
+        <p:spPr>
+          <a:xfrm>
+            <a:off x="863980" y="855015"/>
+            <a:ext cx="7213708" cy="923330"/>
+          </a:xfrm>
+          <a:prstGeom prst="rect">
+            <a:avLst/>
+          </a:prstGeom>
+        </p:spPr>
+        <p:txBody>
+          <a:bodyPr wrap="square">
+            <a:spAutoFit/>
+          </a:bodyPr>
+          <a:lstStyle/>
+          <a:p>
+            <a:pPr algn="ctr"/>
+            <a:r>
+              <a:rPr lang="en-US" sz="5400" b="1" dirty="0">
+                <a:solidFill>
+                  <a:srgbClr val="052B48"/>
+                </a:solidFill>
+                <a:latin typeface="Calibri"/>
+                <a:cs typeface="Calibri"/>
+              </a:rPr>
+              <a:t>Term Set</a:t>
+            </a:r>
+          </a:p>
+        </p:txBody>
+      </p:sp>
+      <p:pic>
+        <p:nvPicPr>
+          <p:cNvPr id="5" name="Picture 4" descr="A screenshot of a computer program&#10;&#10;Description automatically generated">
+            <a:extLst>
+              <a:ext uri="{FF2B5EF4-FFF2-40B4-BE49-F238E27FC236}">
+                <a16:creationId xmlns:a16="http://schemas.microsoft.com/office/drawing/2014/main" id="{2851F3E0-6DDF-3D42-6DD6-F047F89DE89D}"/>
+              </a:ext>
+            </a:extLst>
+          </p:cNvPr>
+          <p:cNvPicPr>
+            <a:picLocks noChangeAspect="1"/>
+          </p:cNvPicPr>
+          <p:nvPr/>
+        </p:nvPicPr>
+        <p:blipFill>
+          <a:blip r:embed="rId2">
+            <a:extLst>
+              <a:ext uri="{28A0092B-C50C-407E-A947-70E740481C1C}">
+                <a14:useLocalDpi xmlns:a14="http://schemas.microsoft.com/office/drawing/2010/main" val="0"/>
+              </a:ext>
+            </a:extLst>
+          </a:blip>
+          <a:srcRect b="3121"/>
+          <a:stretch/>
+        </p:blipFill>
+        <p:spPr>
+          <a:xfrm>
+            <a:off x="1092469" y="1721411"/>
+            <a:ext cx="6748024" cy="3844713"/>
+          </a:xfrm>
+          <a:prstGeom prst="rect">
+            <a:avLst/>
+          </a:prstGeom>
+        </p:spPr>
+      </p:pic>
+      <p:pic>
+        <p:nvPicPr>
+          <p:cNvPr id="8" name="Graphic 7" descr="Checkmark with solid fill">
+            <a:extLst>
+              <a:ext uri="{FF2B5EF4-FFF2-40B4-BE49-F238E27FC236}">
+                <a16:creationId xmlns:a16="http://schemas.microsoft.com/office/drawing/2014/main" id="{3F4CAD09-F09B-12DE-B61E-ABF91DBB5A75}"/>
+              </a:ext>
+            </a:extLst>
+          </p:cNvPr>
+          <p:cNvPicPr>
+            <a:picLocks noChangeAspect="1"/>
+          </p:cNvPicPr>
+          <p:nvPr/>
+        </p:nvPicPr>
+        <p:blipFill>
+          <a:blip r:embed="rId3">
+            <a:extLst>
+              <a:ext uri="{96DAC541-7B7A-43D3-8B79-37D633B846F1}">
+                <asvg:svgBlip xmlns:asvg="http://schemas.microsoft.com/office/drawing/2016/SVG/main" r:embed="rId4"/>
+              </a:ext>
+            </a:extLst>
+          </a:blip>
+          <a:stretch>
+            <a:fillRect/>
+          </a:stretch>
+        </p:blipFill>
+        <p:spPr>
+          <a:xfrm>
+            <a:off x="5828804" y="3584369"/>
+            <a:ext cx="1902031" cy="1902031"/>
+          </a:xfrm>
+          <a:prstGeom prst="rect">
+            <a:avLst/>
+          </a:prstGeom>
+          <a:effectLst>
+            <a:innerShdw blurRad="131865">
+              <a:prstClr val="black"/>
+            </a:innerShdw>
+          </a:effectLst>
+        </p:spPr>
+      </p:pic>
+    </p:spTree>
+    <p:extLst>
+      <p:ext uri="{BB962C8B-B14F-4D97-AF65-F5344CB8AC3E}">
+        <p14:creationId xmlns:p14="http://schemas.microsoft.com/office/powerpoint/2010/main" val="3570217831"/>
+      </p:ext>
+    </p:extLst>
+  </p:cSld>
+  <p:clrMapOvr>
+    <a:masterClrMapping/>
+  </p:clrMapOvr>
+</p:sld>
+</file>
+
 <file path=ppt/theme/theme1.xml><?xml version="1.0" encoding="utf-8"?>
 <a:theme xmlns:a="http://schemas.openxmlformats.org/drawingml/2006/main" name="Simple Light">
   <a:themeElements>

</xml_diff>

<commit_message>
Fix #1203 add missing thumbnail for TermSet tutorial (#1204)
</commit_message>
<xml_diff>
--- a/docs/source/figures/gallery_thumbnails.pptx
+++ b/docs/source/figures/gallery_thumbnails.pptx
@@ -5,7 +5,7 @@
     <p:sldMasterId id="2147483660" r:id="rId1"/>
   </p:sldMasterIdLst>
   <p:notesMasterIdLst>
-    <p:notesMasterId r:id="rId7"/>
+    <p:notesMasterId r:id="rId8"/>
   </p:notesMasterIdLst>
   <p:sldIdLst>
     <p:sldId id="342" r:id="rId2"/>
@@ -13,6 +13,7 @@
     <p:sldId id="344" r:id="rId4"/>
     <p:sldId id="345" r:id="rId5"/>
     <p:sldId id="346" r:id="rId6"/>
+    <p:sldId id="367" r:id="rId7"/>
   </p:sldIdLst>
   <p:sldSz cx="12192000" cy="6858000"/>
   <p:notesSz cx="6858000" cy="9144000"/>
@@ -212,7 +213,7 @@
           <a:p>
             <a:fld id="{4D6A40B9-902A-4E0E-AF39-1C357549AEE0}" type="datetimeFigureOut">
               <a:rPr lang="en-US" smtClean="0"/>
-              <a:t>4/21/22</a:t>
+              <a:t>11/7/24</a:t>
             </a:fld>
             <a:endParaRPr lang="en-US"/>
           </a:p>
@@ -14036,6 +14037,214 @@
 </p:sld>
 </file>
 
+<file path=ppt/slides/slide6.xml><?xml version="1.0" encoding="utf-8"?>
+<p:sld xmlns:a="http://schemas.openxmlformats.org/drawingml/2006/main" xmlns:r="http://schemas.openxmlformats.org/officeDocument/2006/relationships" xmlns:p="http://schemas.openxmlformats.org/presentationml/2006/main">
+  <p:cSld>
+    <p:spTree>
+      <p:nvGrpSpPr>
+        <p:cNvPr id="1" name="">
+          <a:extLst>
+            <a:ext uri="{FF2B5EF4-FFF2-40B4-BE49-F238E27FC236}">
+              <a16:creationId xmlns:a16="http://schemas.microsoft.com/office/drawing/2014/main" id="{71E4B4A6-73B7-86C7-8670-46D8D41DD2E0}"/>
+            </a:ext>
+          </a:extLst>
+        </p:cNvPr>
+        <p:cNvGrpSpPr/>
+        <p:nvPr/>
+      </p:nvGrpSpPr>
+      <p:grpSpPr>
+        <a:xfrm>
+          <a:off x="0" y="0"/>
+          <a:ext cx="0" cy="0"/>
+          <a:chOff x="0" y="0"/>
+          <a:chExt cx="0" cy="0"/>
+        </a:xfrm>
+      </p:grpSpPr>
+      <p:sp>
+        <p:nvSpPr>
+          <p:cNvPr id="27" name="Rounded Rectangle 26">
+            <a:extLst>
+              <a:ext uri="{FF2B5EF4-FFF2-40B4-BE49-F238E27FC236}">
+                <a16:creationId xmlns:a16="http://schemas.microsoft.com/office/drawing/2014/main" id="{5BC30344-1E85-01AE-B374-65D2A28A5CE4}"/>
+              </a:ext>
+            </a:extLst>
+          </p:cNvPr>
+          <p:cNvSpPr/>
+          <p:nvPr/>
+        </p:nvSpPr>
+        <p:spPr>
+          <a:xfrm>
+            <a:off x="853570" y="853671"/>
+            <a:ext cx="7234527" cy="4851352"/>
+          </a:xfrm>
+          <a:prstGeom prst="roundRect">
+            <a:avLst>
+              <a:gd name="adj" fmla="val 4437"/>
+            </a:avLst>
+          </a:prstGeom>
+          <a:solidFill>
+            <a:srgbClr val="EDEDED"/>
+          </a:solidFill>
+          <a:ln>
+            <a:solidFill>
+              <a:srgbClr val="000000"/>
+            </a:solidFill>
+          </a:ln>
+          <a:effectLst/>
+        </p:spPr>
+        <p:style>
+          <a:lnRef idx="1">
+            <a:schemeClr val="accent1"/>
+          </a:lnRef>
+          <a:fillRef idx="3">
+            <a:schemeClr val="accent1"/>
+          </a:fillRef>
+          <a:effectRef idx="2">
+            <a:schemeClr val="accent1"/>
+          </a:effectRef>
+          <a:fontRef idx="minor">
+            <a:schemeClr val="lt1"/>
+          </a:fontRef>
+        </p:style>
+        <p:txBody>
+          <a:bodyPr rtlCol="0" anchor="ctr"/>
+          <a:lstStyle/>
+          <a:p>
+            <a:pPr algn="ctr"/>
+            <a:endParaRPr lang="en-US"/>
+          </a:p>
+        </p:txBody>
+      </p:sp>
+      <p:sp>
+        <p:nvSpPr>
+          <p:cNvPr id="26" name="Rectangle 25">
+            <a:extLst>
+              <a:ext uri="{FF2B5EF4-FFF2-40B4-BE49-F238E27FC236}">
+                <a16:creationId xmlns:a16="http://schemas.microsoft.com/office/drawing/2014/main" id="{217F646C-9719-14B7-7C33-4C1EDEE3A37C}"/>
+              </a:ext>
+            </a:extLst>
+          </p:cNvPr>
+          <p:cNvSpPr/>
+          <p:nvPr/>
+        </p:nvSpPr>
+        <p:spPr>
+          <a:xfrm>
+            <a:off x="863980" y="855015"/>
+            <a:ext cx="7213708" cy="923330"/>
+          </a:xfrm>
+          <a:prstGeom prst="rect">
+            <a:avLst/>
+          </a:prstGeom>
+        </p:spPr>
+        <p:txBody>
+          <a:bodyPr wrap="square">
+            <a:spAutoFit/>
+          </a:bodyPr>
+          <a:lstStyle/>
+          <a:p>
+            <a:pPr algn="ctr"/>
+            <a:r>
+              <a:rPr lang="en-US" sz="5400" b="1" dirty="0">
+                <a:solidFill>
+                  <a:srgbClr val="052B48"/>
+                </a:solidFill>
+                <a:latin typeface="Calibri"/>
+                <a:cs typeface="Calibri"/>
+              </a:rPr>
+              <a:t>Term Set</a:t>
+            </a:r>
+          </a:p>
+        </p:txBody>
+      </p:sp>
+      <p:pic>
+        <p:nvPicPr>
+          <p:cNvPr id="5" name="Picture 4" descr="A screenshot of a computer program&#10;&#10;Description automatically generated">
+            <a:extLst>
+              <a:ext uri="{FF2B5EF4-FFF2-40B4-BE49-F238E27FC236}">
+                <a16:creationId xmlns:a16="http://schemas.microsoft.com/office/drawing/2014/main" id="{2851F3E0-6DDF-3D42-6DD6-F047F89DE89D}"/>
+              </a:ext>
+            </a:extLst>
+          </p:cNvPr>
+          <p:cNvPicPr>
+            <a:picLocks noChangeAspect="1"/>
+          </p:cNvPicPr>
+          <p:nvPr/>
+        </p:nvPicPr>
+        <p:blipFill>
+          <a:blip r:embed="rId2">
+            <a:extLst>
+              <a:ext uri="{28A0092B-C50C-407E-A947-70E740481C1C}">
+                <a14:useLocalDpi xmlns:a14="http://schemas.microsoft.com/office/drawing/2010/main" val="0"/>
+              </a:ext>
+            </a:extLst>
+          </a:blip>
+          <a:srcRect b="3121"/>
+          <a:stretch/>
+        </p:blipFill>
+        <p:spPr>
+          <a:xfrm>
+            <a:off x="1092469" y="1721411"/>
+            <a:ext cx="6748024" cy="3844713"/>
+          </a:xfrm>
+          <a:prstGeom prst="rect">
+            <a:avLst/>
+          </a:prstGeom>
+        </p:spPr>
+      </p:pic>
+      <p:pic>
+        <p:nvPicPr>
+          <p:cNvPr id="8" name="Graphic 7" descr="Checkmark with solid fill">
+            <a:extLst>
+              <a:ext uri="{FF2B5EF4-FFF2-40B4-BE49-F238E27FC236}">
+                <a16:creationId xmlns:a16="http://schemas.microsoft.com/office/drawing/2014/main" id="{3F4CAD09-F09B-12DE-B61E-ABF91DBB5A75}"/>
+              </a:ext>
+            </a:extLst>
+          </p:cNvPr>
+          <p:cNvPicPr>
+            <a:picLocks noChangeAspect="1"/>
+          </p:cNvPicPr>
+          <p:nvPr/>
+        </p:nvPicPr>
+        <p:blipFill>
+          <a:blip r:embed="rId3">
+            <a:extLst>
+              <a:ext uri="{96DAC541-7B7A-43D3-8B79-37D633B846F1}">
+                <asvg:svgBlip xmlns:asvg="http://schemas.microsoft.com/office/drawing/2016/SVG/main" r:embed="rId4"/>
+              </a:ext>
+            </a:extLst>
+          </a:blip>
+          <a:stretch>
+            <a:fillRect/>
+          </a:stretch>
+        </p:blipFill>
+        <p:spPr>
+          <a:xfrm>
+            <a:off x="5828804" y="3584369"/>
+            <a:ext cx="1902031" cy="1902031"/>
+          </a:xfrm>
+          <a:prstGeom prst="rect">
+            <a:avLst/>
+          </a:prstGeom>
+          <a:effectLst>
+            <a:innerShdw blurRad="131865">
+              <a:prstClr val="black"/>
+            </a:innerShdw>
+          </a:effectLst>
+        </p:spPr>
+      </p:pic>
+    </p:spTree>
+    <p:extLst>
+      <p:ext uri="{BB962C8B-B14F-4D97-AF65-F5344CB8AC3E}">
+        <p14:creationId xmlns:p14="http://schemas.microsoft.com/office/powerpoint/2010/main" val="3570217831"/>
+      </p:ext>
+    </p:extLst>
+  </p:cSld>
+  <p:clrMapOvr>
+    <a:masterClrMapping/>
+  </p:clrMapOvr>
+</p:sld>
+</file>
+
 <file path=ppt/theme/theme1.xml><?xml version="1.0" encoding="utf-8"?>
 <a:theme xmlns:a="http://schemas.openxmlformats.org/drawingml/2006/main" name="Simple Light">
   <a:themeElements>

</xml_diff>